<commit_message>
Détecteur externe et ses annotations retirés du projet (DECISIONS n° 184)
- Code : candidats tirés de ses détections retirés (candidates --from, select de même nom),
  règle d'exemption de ses labels retirée ; import-labels, import-detections et la source
  external/<nom> restent, génériques.
- Tests, config, notebooks, documentation, tableaux PNG, présentations, archives : nom retiré.
- Tableau de bord : compteur sans exclusion propre à ce détecteur.

Co-Authored-By: Claude Opus 5.5 <noreply@anthropic.com>
Claude-Session: https://claude.ai/code/session_01SeCekCRpVV6vY8XjvTEFiv
</commit_message>
<xml_diff>
--- a/documentation/prez/presentation_point_etape.pptx
+++ b/documentation/prez/presentation_point_etape.pptx
@@ -1013,7 +1013,7 @@
           <a:lstStyle/>
           <a:p>
             <a:r>
-              <a:t>Le biais de sélection : les 345 positifs sont des détections de Blancinet (score ≥ 0,10) vérifiées à la main. Les chants que Blancinet a ratés n'ont jamais été écoutés. Un détecteur évalué sur ce jeu mesure donc son rappel par rapport à Blancinet, pas par rapport à la réalité : d'où l'audit aléatoire. Deuxième limite, distincte : tout vient de Mataroni, et un seul point (RB04) porte 42 % des positifs.</a:t>
+              <a:t>Le biais de sélection : les 345 positifs sont des détections d'un détecteur externe (score ≥ 0,10) vérifiées à la main. Les chants que ce détecteur a ratés n'ont jamais été écoutés. Un détecteur évalué sur ce jeu mesure donc son rappel par rapport à celui-là, pas par rapport à la réalité : d'où l'audit aléatoire. Deuxième limite, distincte : tout vient de Mataroni, et un seul point (RB04) porte 42 % des positifs.</a:t>
             </a:r>
           </a:p>
         </p:txBody>
@@ -11109,7 +11109,7 @@
                           </a:solidFill>
                           <a:latin typeface="Calibri"/>
                         </a:rPr>
-                        <a:t>Seule mesure du rappel indépendante de Blancinet</a:t>
+                        <a:t>Seule mesure du rappel indépendante de tout détecteur</a:t>
                       </a:r>
                     </a:p>
                   </a:txBody>
@@ -15741,7 +15741,7 @@
                 </a:solidFill>
                 <a:latin typeface="Calibri"/>
               </a:rPr>
-              <a:t>rappel hors du biais Blancinet</a:t>
+              <a:t>rappel hors du biais du détecteur</a:t>
             </a:r>
           </a:p>
         </p:txBody>
@@ -18021,7 +18021,7 @@
                 </a:solidFill>
                 <a:latin typeface="Calibri"/>
               </a:rPr>
-              <a:t>Blancinet est-il bien le modèle de Biophonia ? Et celui de l'étude de 2025 ?</a:t>
+              <a:t>Quel détecteur a servi à l'étude de 2025 ?</a:t>
             </a:r>
           </a:p>
         </p:txBody>
@@ -20183,7 +20183,7 @@
                 </a:solidFill>
                 <a:latin typeface="Calibri"/>
               </a:rPr>
-              <a:t>on n'a écouté que ce que Blancinet avait détecté : les chants qu'il a ratés manquent au jeu</a:t>
+              <a:t>on n'a écouté que ce qu'un détecteur avait remonté : les chants qu'il a ratés manquent au jeu</a:t>
             </a:r>
           </a:p>
         </p:txBody>
@@ -24656,7 +24656,7 @@
                           </a:solidFill>
                           <a:latin typeface="Calibri"/>
                         </a:rPr>
-                        <a:t>Biais de sélection Blancinet</a:t>
+                        <a:t>Biais de sélection du détecteur</a:t>
                       </a:r>
                     </a:p>
                   </a:txBody>

</xml_diff>